<commit_message>
feat: server folder added
</commit_message>
<xml_diff>
--- a/AI_Knowledge_Assistant_Presentation.pptx
+++ b/AI_Knowledge_Assistant_Presentation.pptx
@@ -7379,7 +7379,7 @@
           <a:p>
             <a:pPr algn="l"/>
             <a:r>
-              <a:rPr sz="1100" b="0" i="0">
+              <a:rPr sz="1100" b="0" i="0" dirty="0">
                 <a:solidFill>
                   <a:srgbClr val="1A1A18"/>
                 </a:solidFill>
@@ -7595,7 +7595,7 @@
           <a:p>
             <a:pPr algn="l"/>
             <a:r>
-              <a:rPr sz="1100" b="0" i="0">
+              <a:rPr sz="1100" b="0" i="0" dirty="0">
                 <a:solidFill>
                   <a:srgbClr val="1A1A18"/>
                 </a:solidFill>
@@ -13388,7 +13388,7 @@
           <a:p>
             <a:pPr algn="ctr"/>
             <a:r>
-              <a:rPr sz="1100" b="1">
+              <a:rPr sz="1100" b="1" dirty="0">
                 <a:solidFill>
                   <a:srgbClr val="1D5037"/>
                 </a:solidFill>
@@ -18453,14 +18453,47 @@
           <a:p>
             <a:pPr algn="ctr"/>
             <a:r>
-              <a:rPr sz="1100" b="1">
+              <a:rPr sz="1100" b="1" dirty="0">
                 <a:solidFill>
                   <a:srgbClr val="1D5037"/>
                 </a:solidFill>
                 <a:latin typeface="Calibri"/>
               </a:rPr>
-              <a:t>Store ChromaDB + chunks.json</a:t>
-            </a:r>
+              <a:t>Store </a:t>
+            </a:r>
+            <a:r>
+              <a:rPr sz="1100" b="1" dirty="0" err="1">
+                <a:solidFill>
+                  <a:srgbClr val="1D5037"/>
+                </a:solidFill>
+                <a:latin typeface="Calibri"/>
+              </a:rPr>
+              <a:t>ChromaDB</a:t>
+            </a:r>
+            <a:r>
+              <a:rPr sz="1100" b="1" dirty="0">
+                <a:solidFill>
+                  <a:srgbClr val="1D5037"/>
+                </a:solidFill>
+                <a:latin typeface="Calibri"/>
+              </a:rPr>
+              <a:t> + </a:t>
+            </a:r>
+            <a:r>
+              <a:rPr sz="1100" b="1" dirty="0" err="1">
+                <a:solidFill>
+                  <a:srgbClr val="1D5037"/>
+                </a:solidFill>
+                <a:latin typeface="Calibri"/>
+              </a:rPr>
+              <a:t>chunks.json</a:t>
+            </a:r>
+            <a:endParaRPr sz="1100" b="1" dirty="0">
+              <a:solidFill>
+                <a:srgbClr val="1D5037"/>
+              </a:solidFill>
+              <a:latin typeface="Calibri"/>
+            </a:endParaRPr>
           </a:p>
         </p:txBody>
       </p:sp>
@@ -22229,28 +22262,46 @@
         <p:spPr>
           <a:xfrm>
             <a:off x="548640" y="502920"/>
-            <a:ext cx="10058400" cy="640080"/>
-          </a:xfrm>
-          <a:prstGeom prst="rect">
-            <a:avLst/>
-          </a:prstGeom>
-          <a:noFill/>
-        </p:spPr>
-        <p:txBody>
-          <a:bodyPr wrap="square">
-            <a:spAutoFit/>
-          </a:bodyPr>
-          <a:lstStyle/>
-          <a:p>
-            <a:pPr algn="l"/>
-            <a:r>
-              <a:rPr sz="3000" b="1" i="0">
+            <a:ext cx="10058400" cy="553998"/>
+          </a:xfrm>
+          <a:prstGeom prst="rect">
+            <a:avLst/>
+          </a:prstGeom>
+          <a:noFill/>
+        </p:spPr>
+        <p:txBody>
+          <a:bodyPr wrap="square">
+            <a:spAutoFit/>
+          </a:bodyPr>
+          <a:lstStyle/>
+          <a:p>
+            <a:pPr algn="l"/>
+            <a:r>
+              <a:rPr sz="3000" b="1" i="0" dirty="0">
                 <a:solidFill>
                   <a:srgbClr val="1D5037"/>
                 </a:solidFill>
                 <a:latin typeface="Calibri"/>
               </a:rPr>
-              <a:t>13 Production-Grade Features</a:t>
+              <a:t>1</a:t>
+            </a:r>
+            <a:r>
+              <a:rPr lang="en-IN" sz="3000" b="1" i="0" dirty="0">
+                <a:solidFill>
+                  <a:srgbClr val="1D5037"/>
+                </a:solidFill>
+                <a:latin typeface="Calibri"/>
+              </a:rPr>
+              <a:t>2</a:t>
+            </a:r>
+            <a:r>
+              <a:rPr sz="3000" b="1" i="0" dirty="0">
+                <a:solidFill>
+                  <a:srgbClr val="1D5037"/>
+                </a:solidFill>
+                <a:latin typeface="Calibri"/>
+              </a:rPr>
+              <a:t> Production-Grade Features</a:t>
             </a:r>
           </a:p>
         </p:txBody>

</xml_diff>

<commit_message>
feat: required files added
</commit_message>
<xml_diff>
--- a/AI_Knowledge_Assistant_Presentation.pptx
+++ b/AI_Knowledge_Assistant_Presentation.pptx
@@ -8425,7 +8425,7 @@
           <a:p>
             <a:pPr algn="l"/>
             <a:r>
-              <a:rPr sz="3000" b="1" i="0">
+              <a:rPr sz="3000" b="1" i="0" dirty="0">
                 <a:solidFill>
                   <a:srgbClr val="1A3D5C"/>
                 </a:solidFill>
@@ -8596,7 +8596,7 @@
           <a:p>
             <a:pPr algn="l"/>
             <a:r>
-              <a:rPr sz="1400" b="1" i="0">
+              <a:rPr sz="1400" b="1" i="0" dirty="0">
                 <a:solidFill>
                   <a:srgbClr val="FFFFFF"/>
                 </a:solidFill>

</xml_diff>